<commit_message>
docs: update live demo link to AWS EC2 (http://13.59.83.134) in README and PPTX
</commit_message>
<xml_diff>
--- a/ZeroHarm_AI_Presentation.pptx
+++ b/ZeroHarm_AI_Presentation.pptx
@@ -5530,7 +5530,7 @@
               </a:defRPr>
             </a:pPr>
             <a:r>
-              <a:t>Docker: docker compose up -d (backend :8000, frontend :8080)</a:t>
+              <a:t>Docker: docker compose up -d (backend :8000, frontend :80)</a:t>
             </a:r>
             <a:br/>
             <a:r>
@@ -6004,7 +6004,7 @@
               </a:defRPr>
             </a:pPr>
             <a:r>
-              <a:t>Live Demo: https://zero-harmer-frontend.onrender.com</a:t>
+              <a:t>Live Demo: http://13.59.83.134</a:t>
             </a:r>
           </a:p>
         </p:txBody>
@@ -10652,7 +10652,7 @@
               </a:defRPr>
             </a:pPr>
             <a:r>
-              <a:t>Render (free tier — 512MB)</a:t>
+              <a:t>AWS EC2 (t2.micro)</a:t>
             </a:r>
           </a:p>
         </p:txBody>

</xml_diff>